<commit_message>
Coloca a Profa. Isabella como orientadora na apresentação
Co-Authored-By: Claude Opus 5.5 <noreply@anthropic.com>
Claude-Session: https://claude.ai/code/session_016JENYZ3RA8AT9q53QsyHEN
</commit_message>
<xml_diff>
--- a/Apresentacao_Gustavo_Luiz_Luchesi.pptx
+++ b/Apresentacao_Gustavo_Luiz_Luchesi.pptx
@@ -5106,7 +5106,7 @@
                 <a:latin typeface="Verdana" panose="020B0604030504040204" pitchFamily="34" charset="0"/>
                 <a:ea typeface="ＭＳ Ｐゴシック" panose="020B0600070205080204" pitchFamily="34" charset="-128"/>
               </a:rPr>
-              <a:t>Profa</a:t>
+              <a:t>Profa. Isabella Luiza dos Santos Souza, Esp.</a:t>
             </a:r>
             <a:r>
               <a:rPr lang="pt-BR" altLang="pt-BR" sz="1200" b="1" dirty="0">
@@ -5116,42 +5116,8 @@
                 <a:latin typeface="Verdana" panose="020B0604030504040204" pitchFamily="34" charset="0"/>
                 <a:ea typeface="ＭＳ Ｐゴシック" panose="020B0600070205080204" pitchFamily="34" charset="-128"/>
               </a:rPr>
-              <a:t>. Renata Costa, Me</a:t>
-            </a:r>
-          </a:p>
-          <a:p>
-            <a:pPr>
-              <a:spcBef>
-                <a:spcPct val="50000"/>
-              </a:spcBef>
-            </a:pPr>
-            <a:r>
-              <a:rPr lang="pt-BR" altLang="pt-BR" sz="1200" b="1" dirty="0">
-                <a:solidFill>
-                  <a:srgbClr val="153553"/>
-                </a:solidFill>
-                <a:latin typeface="Verdana" panose="020B0604030504040204" pitchFamily="34" charset="0"/>
-                <a:ea typeface="ＭＳ Ｐゴシック" panose="020B0600070205080204" pitchFamily="34" charset="-128"/>
-              </a:rPr>
-              <a:t>Profa. Andrea Ono, </a:t>
-            </a:r>
-            <a:r>
-              <a:rPr lang="pt-BR" altLang="pt-BR" sz="1200" b="1" dirty="0" err="1">
-                <a:solidFill>
-                  <a:srgbClr val="153553"/>
-                </a:solidFill>
-                <a:latin typeface="Verdana" panose="020B0604030504040204" pitchFamily="34" charset="0"/>
-                <a:ea typeface="ＭＳ Ｐゴシック" panose="020B0600070205080204" pitchFamily="34" charset="-128"/>
-              </a:rPr>
-              <a:t>Dr</a:t>
-            </a:r>
-            <a:endParaRPr lang="pt-BR" altLang="pt-BR" sz="1200" b="1" dirty="0">
-              <a:solidFill>
-                <a:srgbClr val="153553"/>
-              </a:solidFill>
-              <a:latin typeface="Verdana" panose="020B0604030504040204" pitchFamily="34" charset="0"/>
-              <a:ea typeface="ＭＳ Ｐゴシック" panose="020B0600070205080204" pitchFamily="34" charset="-128"/>
-            </a:endParaRPr>
+              <a:t/>
+            </a:r>
           </a:p>
           <a:p>
             <a:pPr>

</xml_diff>

<commit_message>
Inclui citações com página, confere referências e conclui a revisão final
Co-Authored-By: Claude Opus 5.5 <noreply@anthropic.com>
Claude-Session: https://claude.ai/code/session_016JENYZ3RA8AT9q53QsyHEN
</commit_message>
<xml_diff>
--- a/Apresentacao_Gustavo_Luiz_Luchesi.pptx
+++ b/Apresentacao_Gustavo_Luiz_Luchesi.pptx
@@ -9628,7 +9628,7 @@
                 <a:latin typeface="Verdana" pitchFamily="34" charset="0"/>
                 <a:ea typeface="Verdana" pitchFamily="34" charset="0"/>
               </a:rPr>
-              <a:t xml:space="preserve">BARROS, Ygor Santos; OUTÃO, Juliana Carvalho Silva do; SACRAMENTO, Carolina; FERREIRA, Simone Bacellar Leal; PIMENTEL, Mariano Gomes; SANTOS, Rodrigo Pereira dos. Avaliação de acessibilidade da plataforma Gov.br por ferramentas automatizadas. In: LATIN AMERICAN SYMPOSIUM ON DIGITAL GOVERNMENT (LASDiGov), 12., 2024, Brasília. </a:t>
+              <a:t xml:space="preserve">BARROS, Ygor Santos; OUTÃO, Juliana Carvalho Silva do; SACRAMENTO, Carolina; FERREIRA, Simone Bacellar Leal; PIMENTEL, Mariano Gomes; SANTOS, Rodrigo Pereira dos. Avaliação de acessibilidade da plataforma Gov.br por ferramentas automatizadas. In: WORKSHOP DE COMPUTAÇÃO APLICADA EM GOVERNO ELETRÔNICO (WCGE), 12., 2024, Brasília. </a:t>
             </a:r>
             <a:r>
               <a:rPr lang="pt-BR" sz="1000" b="1" dirty="0">
@@ -9672,7 +9672,7 @@
                 <a:latin typeface="Verdana" pitchFamily="34" charset="0"/>
                 <a:ea typeface="Verdana" pitchFamily="34" charset="0"/>
               </a:rPr>
-              <a:t xml:space="preserve">, v. 18, n. 1, p. 14:1-14:27, 2026.</a:t>
+              <a:t xml:space="preserve">, v. 18, n. 1, p. 14:1-14:27, 2026. DOI: 10.5753/isys.2025.5401.</a:t>
             </a:r>
           </a:p>
           <a:p>

</xml_diff>